<commit_message>
decks: update cover header to 'AIx{} Project / Uraki-Takahashi Laboratory'
</commit_message>
<xml_diff>
--- a/docs/20260709_Research_Lifecycle_Guide_v7_EN.pptx
+++ b/docs/20260709_Research_Lifecycle_Guide_v7_EN.pptx
@@ -4646,7 +4646,7 @@
                 <a:ea typeface="Arial" pitchFamily="34" charset="-122"/>
                 <a:cs typeface="Arial" pitchFamily="34" charset="-120"/>
               </a:rPr>
-              <a:t>MUSASHINO UNIVERSITY  -  FACULTY OF DATA SCIENCE</a:t>
+              <a:t>AIx{} Project  -  Uraki-Takahashi Laboratory</a:t>
             </a:r>
             <a:endParaRPr lang="en-US" sz="1200" dirty="0"/>
           </a:p>
@@ -44076,7 +44076,7 @@
               <a:buNone/>
             </a:pPr>
             <a:r>
-              <a:rPr lang="en-US" sz="950" dirty="0">
+              <a:rPr lang="en-US" sz="900" dirty="0">
                 <a:solidFill>
                   <a:srgbClr val="8FB8C6"/>
                 </a:solidFill>
@@ -44084,9 +44084,9 @@
                 <a:ea typeface="Arial" pitchFamily="34" charset="-122"/>
                 <a:cs typeface="Arial" pitchFamily="34" charset="-120"/>
               </a:rPr>
-              <a:t>Acknowledgment: Prof. Souichi Oka (Musashino University, Faculty of Data Science) / based on the Uraki method (7-sentence abstract, hako template A/B, fill-in editor)</a:t>
-            </a:r>
-            <a:endParaRPr lang="en-US" sz="950" dirty="0"/>
+              <a:t>Acknowledgment: Prof. Souichi Oka (Musashino Univ., DS) - feedback &amp; advice  /  Assoc. Prof. Asako Uraki (same) - 7-sentence abstract, hako template A/B, fill-in editor</a:t>
+            </a:r>
+            <a:endParaRPr lang="en-US" sz="900" dirty="0"/>
           </a:p>
         </p:txBody>
       </p:sp>
@@ -44123,7 +44123,7 @@
                 <a:ea typeface="Arial" pitchFamily="34" charset="-122"/>
                 <a:cs typeface="Arial" pitchFamily="34" charset="-120"/>
               </a:rPr>
-              <a:t>Musashino University, Faculty of Data Science  |  Research Lifecycle Guide [Learning Edition]  v7 / 2026-07-09 / EN</a:t>
+              <a:t>AIx{} Project, Uraki-Takahashi Laboratory (Musashino University, Faculty of Data Science)  |  Research Lifecycle Guide [Learning Edition]  v7 / 2026-07-09 / EN</a:t>
             </a:r>
             <a:endParaRPr lang="en-US" sz="950" dirty="0"/>
           </a:p>

</xml_diff>

<commit_message>
docs: add English guide (ResearchLifecycleGuide_EN.md), remove v6 deck
</commit_message>
<xml_diff>
--- a/docs/20260709_Research_Lifecycle_Guide_v7_EN.pptx
+++ b/docs/20260709_Research_Lifecycle_Guide_v7_EN.pptx
@@ -11631,7 +11631,7 @@
                 <a:ea typeface="Arial" pitchFamily="34" charset="-122"/>
                 <a:cs typeface="Arial" pitchFamily="34" charset="-120"/>
               </a:rPr>
-              <a:t>The 7-sentence abstract (Uraki)</a:t>
+              <a:t>The 7-sentence abstract (A. Uraki)</a:t>
             </a:r>
             <a:endParaRPr lang="en-US" sz="950" dirty="0"/>
           </a:p>
@@ -20653,7 +20653,7 @@
                 <a:ea typeface="Arial" pitchFamily="34" charset="-122"/>
                 <a:cs typeface="Arial" pitchFamily="34" charset="-120"/>
               </a:rPr>
-              <a:t>PART 3  -  CHOOSING THE WRITING FORMAT (URAKI METHOD)</a:t>
+              <a:t>PART 3  -  CHOOSING THE WRITING FORMAT (BY ASSOC. PROF. ASAKO URAKI)</a:t>
             </a:r>
             <a:endParaRPr lang="en-US" sz="1200" dirty="0"/>
           </a:p>
@@ -21967,7 +21967,7 @@
                 <a:ea typeface="Arial" pitchFamily="34" charset="-122"/>
                 <a:cs typeface="Arial" pitchFamily="34" charset="-120"/>
               </a:rPr>
-              <a:t>PART 3  -  URAKI METHOD</a:t>
+              <a:t>PART 3  -  BY ASSOC. PROF. ASAKO URAKI</a:t>
             </a:r>
             <a:endParaRPr lang="en-US" sz="1200" dirty="0"/>
           </a:p>
@@ -40689,7 +40689,7 @@
                           <a:ea typeface="Arial" pitchFamily="34" charset="-122"/>
                           <a:cs typeface="Arial" pitchFamily="34" charset="-120"/>
                         </a:rPr>
-                        <a:t>Includes the Uraki method (7 sentences, hako template)</a:t>
+                        <a:t>Includes A. Uraki's 7 sentences &amp; hako template</a:t>
                       </a:r>
                       <a:endParaRPr lang="en-US" sz="850" dirty="0">
                         <a:latin typeface="Arial" charset="0"/>

</xml_diff>